<commit_message>
fix(deck): rebuild S14 pricing chart as shapes (renders in every engine incl. Keynote/PDF)
Native pptxgenjs chart was dropped on Keynote PDF export. Replaced with shape-based
horizontal bars + target-band highlight. Visual QA (subagent): 16/17 clean; S14 was the
only defect, now fixed. Hebrew + shekel render correctly.

Co-Authored-By: Claude Opus 4.8 <noreply@anthropic.com>
</commit_message>
<xml_diff>
--- a/_COMMUNICATION/TEAM_100/SFA-S004-RESEARCH-SUMMARY/SFA_Research_Summary_2026-06-05.pptx
+++ b/_COMMUNICATION/TEAM_100/SFA-S004-RESEARCH-SUMMARY/SFA_Research_Summary_2026-06-05.pptx
@@ -121,278 +121,6 @@
     </a:lvl9pPr>
   </p:defaultTextStyle>
 </p:presentation>
-</file>
-
-<file path=ppt/charts/chart1.xml><?xml version="1.0" encoding="utf-8"?>
-<c:chartSpace xmlns:c="http://schemas.openxmlformats.org/drawingml/2006/chart" xmlns:a="http://schemas.openxmlformats.org/drawingml/2006/main" xmlns:r="http://schemas.openxmlformats.org/officeDocument/2006/relationships">
-  <c:date1904 val="0"/>
-  <c:roundedCorners val="1"/>
-  <c:chart>
-    <c:autoTitleDeleted val="1"/>
-    <c:plotArea>
-      <c:layout/>
-      <c:barChart>
-        <c:barDir val="col"/>
-        <c:grouping val="clustered"/>
-        <c:varyColors val="0"/>
-        <c:ser>
-          <c:idx val="0"/>
-          <c:order val="0"/>
-          <c:tx>
-            <c:strRef>
-              <c:f>Sheet1!$B$1</c:f>
-              <c:strCache>
-                <c:ptCount val="1"/>
-                <c:pt idx="0">
-                  <c:v>$/mo (equiv.)</c:v>
-                </c:pt>
-              </c:strCache>
-            </c:strRef>
-          </c:tx>
-          <c:spPr>
-            <a:solidFill>
-              <a:srgbClr val="2E7D4F"/>
-            </a:solidFill>
-            <a:effectLst/>
-          </c:spPr>
-          <c:invertIfNegative val="0"/>
-          <c:dLbls>
-            <c:numFmt formatCode="#,##0" sourceLinked="0"/>
-            <c:txPr>
-              <a:bodyPr/>
-              <a:lstStyle/>
-              <a:p>
-                <a:pPr>
-                  <a:defRPr b="0" i="0" strike="noStrike" sz="900" u="none">
-                    <a:solidFill>
-                      <a:srgbClr val="1A2620"/>
-                    </a:solidFill>
-                    <a:latin typeface="Arial"/>
-                  </a:defRPr>
-                </a:pPr>
-              </a:p>
-            </c:txPr>
-            <c:showLegendKey val="0"/>
-            <c:showVal val="1"/>
-            <c:showCatName val="0"/>
-            <c:showSerName val="0"/>
-            <c:showPercent val="0"/>
-            <c:showBubbleSize val="0"/>
-            <c:showLeaderLines val="0"/>
-          </c:dLbls>
-          <c:cat>
-            <c:multiLvlStrRef>
-              <c:f>Sheet1!$A$2:$A$9</c:f>
-              <c:multiLvlStrCache>
-                <c:ptCount val="8"/>
-                <c:lvl>
-                  <c:pt idx="0">
-                    <c:v>Seedtime</c:v>
-                  </c:pt>
-                  <c:pt idx="1">
-                    <c:v>MyGardenPlanner</c:v>
-                  </c:pt>
-                  <c:pt idx="2">
-                    <c:v>Farmbrite</c:v>
-                  </c:pt>
-                  <c:pt idx="3">
-                    <c:v>Tend Pro</c:v>
-                  </c:pt>
-                  <c:pt idx="4">
-                    <c:v>VeggieCropper</c:v>
-                  </c:pt>
-                  <c:pt idx="5">
-                    <c:v>AgriWebb</c:v>
-                  </c:pt>
-                  <c:pt idx="6">
-                    <c:v>Local Line</c:v>
-                  </c:pt>
-                  <c:pt idx="7">
-                    <c:v>Solara</c:v>
-                  </c:pt>
-                </c:lvl>
-              </c:multiLvlStrCache>
-            </c:multiLvlStrRef>
-          </c:cat>
-          <c:val>
-            <c:numRef>
-              <c:f>Sheet1!$B$2:$B$9</c:f>
-              <c:numCache>
-                <c:formatCode>General</c:formatCode>
-                <c:ptCount val="8"/>
-                <c:pt idx="0">
-                  <c:v>14</c:v>
-                </c:pt>
-                <c:pt idx="1">
-                  <c:v>19</c:v>
-                </c:pt>
-                <c:pt idx="2">
-                  <c:v>29</c:v>
-                </c:pt>
-                <c:pt idx="3">
-                  <c:v>30</c:v>
-                </c:pt>
-                <c:pt idx="4">
-                  <c:v>37</c:v>
-                </c:pt>
-                <c:pt idx="5">
-                  <c:v>55</c:v>
-                </c:pt>
-                <c:pt idx="6">
-                  <c:v>99</c:v>
-                </c:pt>
-                <c:pt idx="7">
-                  <c:v>99</c:v>
-                </c:pt>
-              </c:numCache>
-            </c:numRef>
-          </c:val>
-        </c:ser>
-        <c:dLbls>
-          <c:numFmt formatCode="#,##0" sourceLinked="0"/>
-          <c:txPr>
-            <a:bodyPr/>
-            <a:lstStyle/>
-            <a:p>
-              <a:pPr>
-                <a:defRPr b="0" i="0" strike="noStrike" sz="900" u="none">
-                  <a:solidFill>
-                    <a:srgbClr val="1A2620"/>
-                  </a:solidFill>
-                  <a:latin typeface="Arial"/>
-                </a:defRPr>
-              </a:pPr>
-            </a:p>
-          </c:txPr>
-          <c:showLegendKey val="0"/>
-          <c:showVal val="1"/>
-          <c:showCatName val="0"/>
-          <c:showSerName val="0"/>
-          <c:showPercent val="0"/>
-          <c:showBubbleSize val="0"/>
-          <c:showLeaderLines val="0"/>
-        </c:dLbls>
-        <c:gapWidth val="150"/>
-        <c:overlap val="0"/>
-        <c:axId val="2094734554"/>
-        <c:axId val="2094734552"/>
-        <c:axId val="2094734556"/>
-      </c:barChart>
-      <c:catAx>
-        <c:axId val="2094734554"/>
-        <c:scaling>
-          <c:orientation val="minMax"/>
-        </c:scaling>
-        <c:delete val="0"/>
-        <c:axPos val="b"/>
-        <c:numFmt formatCode="General" sourceLinked="1"/>
-        <c:majorTickMark val="out"/>
-        <c:minorTickMark val="none"/>
-        <c:tickLblPos val="low"/>
-        <c:spPr>
-          <a:ln w="12700" cap="flat">
-            <a:solidFill>
-              <a:srgbClr val="888888"/>
-            </a:solidFill>
-            <a:prstDash val="solid"/>
-            <a:round/>
-          </a:ln>
-        </c:spPr>
-        <c:txPr>
-          <a:bodyPr/>
-          <a:lstStyle/>
-          <a:p>
-            <a:pPr>
-              <a:defRPr sz="900" b="0" i="0" u="none" strike="noStrike">
-                <a:solidFill>
-                  <a:srgbClr val="5C6B60"/>
-                </a:solidFill>
-                <a:latin typeface="Arial"/>
-              </a:defRPr>
-            </a:pPr>
-            <a:endParaRPr lang="en-US"/>
-          </a:p>
-        </c:txPr>
-        <c:crossAx val="2094734552"/>
-        <c:crosses val="autoZero"/>
-        <c:auto val="1"/>
-        <c:lblAlgn val="ctr"/>
-        <c:noMultiLvlLbl val="1"/>
-      </c:catAx>
-      <c:valAx>
-        <c:axId val="2094734552"/>
-        <c:scaling>
-          <c:orientation val="minMax"/>
-        </c:scaling>
-        <c:delete val="1"/>
-        <c:axPos val="l"/>
-        <c:majorGridlines>
-          <c:spPr>
-            <a:ln w="6350" cap="flat">
-              <a:solidFill>
-                <a:srgbClr val="E2E8F0"/>
-              </a:solidFill>
-              <a:prstDash val="solid"/>
-              <a:round/>
-            </a:ln>
-          </c:spPr>
-        </c:majorGridlines>
-        <c:numFmt formatCode="General" sourceLinked="0"/>
-        <c:majorTickMark val="out"/>
-        <c:minorTickMark val="none"/>
-        <c:tickLblPos val="nextTo"/>
-        <c:spPr>
-          <a:ln w="12700" cap="flat">
-            <a:solidFill>
-              <a:srgbClr val="888888"/>
-            </a:solidFill>
-            <a:prstDash val="solid"/>
-            <a:round/>
-          </a:ln>
-        </c:spPr>
-        <c:txPr>
-          <a:bodyPr/>
-          <a:lstStyle/>
-          <a:p>
-            <a:pPr>
-              <a:defRPr sz="1200" b="0" i="0" u="none" strike="noStrike">
-                <a:solidFill>
-                  <a:srgbClr val="5C6B60"/>
-                </a:solidFill>
-                <a:latin typeface="Arial"/>
-              </a:defRPr>
-            </a:pPr>
-            <a:endParaRPr lang="en-US"/>
-          </a:p>
-        </c:txPr>
-        <c:crossAx val="2094734554"/>
-        <c:crosses val="autoZero"/>
-        <c:crossBetween val="between"/>
-      </c:valAx>
-      <c:spPr>
-        <a:noFill/>
-        <a:ln>
-          <a:noFill/>
-        </a:ln>
-        <a:effectLst/>
-      </c:spPr>
-    </c:plotArea>
-    <c:plotVisOnly val="1"/>
-    <c:dispBlanksAs val="span"/>
-  </c:chart>
-  <c:spPr>
-    <a:solidFill>
-      <a:srgbClr val="FFFFFF"/>
-    </a:solidFill>
-    <a:ln>
-      <a:noFill/>
-    </a:ln>
-    <a:effectLst/>
-  </c:spPr>
-  <c:externalData r:id="rId1">
-    <c:autoUpdate val="0"/>
-  </c:externalData>
-</c:chartSpace>
 </file>
 
 <file path=ppt/notesMasters/notesMaster1.xml><?xml version="1.0" encoding="utf-8"?>
@@ -5787,25 +5515,893 @@
           </a:p>
         </p:txBody>
       </p:sp>
-      <p:graphicFrame>
-        <p:nvGraphicFramePr>
-          <p:cNvPr id="4" name="Chart 0" descr=""/>
-          <p:cNvGraphicFramePr/>
-          <p:nvPr/>
-        </p:nvGraphicFramePr>
-        <p:xfrm>
-          <a:off x="640080" y="1828800"/>
-          <a:ext cx="7040880" cy="3931920"/>
-        </p:xfrm>
-        <a:graphic xmlns:a="http://schemas.openxmlformats.org/drawingml/2006/main">
-          <a:graphicData uri="http://schemas.openxmlformats.org/drawingml/2006/chart">
-            <c:chart xmlns:c="http://schemas.openxmlformats.org/drawingml/2006/chart" r:id="rId1"/>
-          </a:graphicData>
-        </a:graphic>
-      </p:graphicFrame>
-      <p:sp>
-        <p:nvSpPr>
-          <p:cNvPr id="5" name="Shape 2"/>
+      <p:sp>
+        <p:nvSpPr>
+          <p:cNvPr id="4" name="Shape 2"/>
+          <p:cNvSpPr/>
+          <p:nvPr/>
+        </p:nvSpPr>
+        <p:spPr>
+          <a:xfrm>
+            <a:off x="3669030" y="2039112"/>
+            <a:ext cx="555498" cy="3694176"/>
+          </a:xfrm>
+          <a:prstGeom prst="rect">
+            <a:avLst/>
+          </a:prstGeom>
+          <a:solidFill>
+            <a:srgbClr val="D8A24A">
+              <a:alpha val="20000"/>
+            </a:srgbClr>
+          </a:solidFill>
+          <a:ln/>
+        </p:spPr>
+      </p:sp>
+      <p:sp>
+        <p:nvSpPr>
+          <p:cNvPr id="5" name="Text 3"/>
+          <p:cNvSpPr/>
+          <p:nvPr/>
+        </p:nvSpPr>
+        <p:spPr>
+          <a:xfrm>
+            <a:off x="3166110" y="1673352"/>
+            <a:ext cx="1554480" cy="292608"/>
+          </a:xfrm>
+          <a:prstGeom prst="rect">
+            <a:avLst/>
+          </a:prstGeom>
+          <a:noFill/>
+          <a:ln/>
+        </p:spPr>
+        <p:txBody>
+          <a:bodyPr wrap="square" lIns="0" tIns="0" rIns="0" bIns="0" rtlCol="0" anchor="ctr"/>
+          <a:lstStyle/>
+          <a:p>
+            <a:pPr algn="ctr" indent="0" marL="0">
+              <a:buNone/>
+            </a:pPr>
+            <a:r>
+              <a:rPr lang="en-US" sz="900" b="1" dirty="0">
+                <a:solidFill>
+                  <a:srgbClr val="D8A24A"/>
+                </a:solidFill>
+                <a:latin typeface="Calibri" pitchFamily="34" charset="0"/>
+                <a:ea typeface="Calibri" pitchFamily="34" charset="-122"/>
+                <a:cs typeface="Calibri" pitchFamily="34" charset="-120"/>
+              </a:rPr>
+              <a:t>target band</a:t>
+            </a:r>
+            <a:endParaRPr lang="en-US" sz="900" dirty="0"/>
+          </a:p>
+        </p:txBody>
+      </p:sp>
+      <p:sp>
+        <p:nvSpPr>
+          <p:cNvPr id="6" name="Text 4"/>
+          <p:cNvSpPr/>
+          <p:nvPr/>
+        </p:nvSpPr>
+        <p:spPr>
+          <a:xfrm>
+            <a:off x="640080" y="2057400"/>
+            <a:ext cx="1920240" cy="402336"/>
+          </a:xfrm>
+          <a:prstGeom prst="rect">
+            <a:avLst/>
+          </a:prstGeom>
+          <a:noFill/>
+          <a:ln/>
+        </p:spPr>
+        <p:txBody>
+          <a:bodyPr wrap="square" lIns="0" tIns="0" rIns="0" bIns="0" rtlCol="0" anchor="ctr"/>
+          <a:lstStyle/>
+          <a:p>
+            <a:pPr algn="r" indent="0" marL="0">
+              <a:buNone/>
+            </a:pPr>
+            <a:r>
+              <a:rPr lang="en-US" sz="1050" dirty="0">
+                <a:solidFill>
+                  <a:srgbClr val="1A2620"/>
+                </a:solidFill>
+                <a:latin typeface="Calibri" pitchFamily="34" charset="0"/>
+                <a:ea typeface="Calibri" pitchFamily="34" charset="-122"/>
+                <a:cs typeface="Calibri" pitchFamily="34" charset="-120"/>
+              </a:rPr>
+              <a:t>Seedtime</a:t>
+            </a:r>
+            <a:endParaRPr lang="en-US" sz="1050" dirty="0"/>
+          </a:p>
+        </p:txBody>
+      </p:sp>
+      <p:sp>
+        <p:nvSpPr>
+          <p:cNvPr id="7" name="Shape 5"/>
+          <p:cNvSpPr/>
+          <p:nvPr/>
+        </p:nvSpPr>
+        <p:spPr>
+          <a:xfrm>
+            <a:off x="2743200" y="2130552"/>
+            <a:ext cx="518465" cy="274320"/>
+          </a:xfrm>
+          <a:prstGeom prst="rect">
+            <a:avLst/>
+          </a:prstGeom>
+          <a:solidFill>
+            <a:srgbClr val="2E7D4F"/>
+          </a:solidFill>
+          <a:ln/>
+        </p:spPr>
+      </p:sp>
+      <p:sp>
+        <p:nvSpPr>
+          <p:cNvPr id="8" name="Text 6"/>
+          <p:cNvSpPr/>
+          <p:nvPr/>
+        </p:nvSpPr>
+        <p:spPr>
+          <a:xfrm>
+            <a:off x="3334817" y="2057400"/>
+            <a:ext cx="731520" cy="402336"/>
+          </a:xfrm>
+          <a:prstGeom prst="rect">
+            <a:avLst/>
+          </a:prstGeom>
+          <a:noFill/>
+          <a:ln/>
+        </p:spPr>
+        <p:txBody>
+          <a:bodyPr wrap="square" lIns="0" tIns="0" rIns="0" bIns="0" rtlCol="0" anchor="ctr"/>
+          <a:lstStyle/>
+          <a:p>
+            <a:pPr indent="0" marL="0">
+              <a:buNone/>
+            </a:pPr>
+            <a:r>
+              <a:rPr lang="en-US" sz="1000" b="1" dirty="0">
+                <a:solidFill>
+                  <a:srgbClr val="5C6B60"/>
+                </a:solidFill>
+                <a:latin typeface="Calibri" pitchFamily="34" charset="0"/>
+                <a:ea typeface="Calibri" pitchFamily="34" charset="-122"/>
+                <a:cs typeface="Calibri" pitchFamily="34" charset="-120"/>
+              </a:rPr>
+              <a:t>$14</a:t>
+            </a:r>
+            <a:endParaRPr lang="en-US" sz="1000" dirty="0"/>
+          </a:p>
+        </p:txBody>
+      </p:sp>
+      <p:sp>
+        <p:nvSpPr>
+          <p:cNvPr id="9" name="Text 7"/>
+          <p:cNvSpPr/>
+          <p:nvPr/>
+        </p:nvSpPr>
+        <p:spPr>
+          <a:xfrm>
+            <a:off x="640080" y="2514600"/>
+            <a:ext cx="1920240" cy="402336"/>
+          </a:xfrm>
+          <a:prstGeom prst="rect">
+            <a:avLst/>
+          </a:prstGeom>
+          <a:noFill/>
+          <a:ln/>
+        </p:spPr>
+        <p:txBody>
+          <a:bodyPr wrap="square" lIns="0" tIns="0" rIns="0" bIns="0" rtlCol="0" anchor="ctr"/>
+          <a:lstStyle/>
+          <a:p>
+            <a:pPr algn="r" indent="0" marL="0">
+              <a:buNone/>
+            </a:pPr>
+            <a:r>
+              <a:rPr lang="en-US" sz="1050" dirty="0">
+                <a:solidFill>
+                  <a:srgbClr val="1A2620"/>
+                </a:solidFill>
+                <a:latin typeface="Calibri" pitchFamily="34" charset="0"/>
+                <a:ea typeface="Calibri" pitchFamily="34" charset="-122"/>
+                <a:cs typeface="Calibri" pitchFamily="34" charset="-120"/>
+              </a:rPr>
+              <a:t>MyGardenPlanner</a:t>
+            </a:r>
+            <a:endParaRPr lang="en-US" sz="1050" dirty="0"/>
+          </a:p>
+        </p:txBody>
+      </p:sp>
+      <p:sp>
+        <p:nvSpPr>
+          <p:cNvPr id="10" name="Shape 8"/>
+          <p:cNvSpPr/>
+          <p:nvPr/>
+        </p:nvSpPr>
+        <p:spPr>
+          <a:xfrm>
+            <a:off x="2743200" y="2587752"/>
+            <a:ext cx="703631" cy="274320"/>
+          </a:xfrm>
+          <a:prstGeom prst="rect">
+            <a:avLst/>
+          </a:prstGeom>
+          <a:solidFill>
+            <a:srgbClr val="2E7D4F"/>
+          </a:solidFill>
+          <a:ln/>
+        </p:spPr>
+      </p:sp>
+      <p:sp>
+        <p:nvSpPr>
+          <p:cNvPr id="11" name="Text 9"/>
+          <p:cNvSpPr/>
+          <p:nvPr/>
+        </p:nvSpPr>
+        <p:spPr>
+          <a:xfrm>
+            <a:off x="3519983" y="2514600"/>
+            <a:ext cx="731520" cy="402336"/>
+          </a:xfrm>
+          <a:prstGeom prst="rect">
+            <a:avLst/>
+          </a:prstGeom>
+          <a:noFill/>
+          <a:ln/>
+        </p:spPr>
+        <p:txBody>
+          <a:bodyPr wrap="square" lIns="0" tIns="0" rIns="0" bIns="0" rtlCol="0" anchor="ctr"/>
+          <a:lstStyle/>
+          <a:p>
+            <a:pPr indent="0" marL="0">
+              <a:buNone/>
+            </a:pPr>
+            <a:r>
+              <a:rPr lang="en-US" sz="1000" b="1" dirty="0">
+                <a:solidFill>
+                  <a:srgbClr val="5C6B60"/>
+                </a:solidFill>
+                <a:latin typeface="Calibri" pitchFamily="34" charset="0"/>
+                <a:ea typeface="Calibri" pitchFamily="34" charset="-122"/>
+                <a:cs typeface="Calibri" pitchFamily="34" charset="-120"/>
+              </a:rPr>
+              <a:t>$19</a:t>
+            </a:r>
+            <a:endParaRPr lang="en-US" sz="1000" dirty="0"/>
+          </a:p>
+        </p:txBody>
+      </p:sp>
+      <p:sp>
+        <p:nvSpPr>
+          <p:cNvPr id="12" name="Text 10"/>
+          <p:cNvSpPr/>
+          <p:nvPr/>
+        </p:nvSpPr>
+        <p:spPr>
+          <a:xfrm>
+            <a:off x="640080" y="2971800"/>
+            <a:ext cx="1920240" cy="402336"/>
+          </a:xfrm>
+          <a:prstGeom prst="rect">
+            <a:avLst/>
+          </a:prstGeom>
+          <a:noFill/>
+          <a:ln/>
+        </p:spPr>
+        <p:txBody>
+          <a:bodyPr wrap="square" lIns="0" tIns="0" rIns="0" bIns="0" rtlCol="0" anchor="ctr"/>
+          <a:lstStyle/>
+          <a:p>
+            <a:pPr algn="r" indent="0" marL="0">
+              <a:buNone/>
+            </a:pPr>
+            <a:r>
+              <a:rPr lang="en-US" sz="1050" dirty="0">
+                <a:solidFill>
+                  <a:srgbClr val="1A2620"/>
+                </a:solidFill>
+                <a:latin typeface="Calibri" pitchFamily="34" charset="0"/>
+                <a:ea typeface="Calibri" pitchFamily="34" charset="-122"/>
+                <a:cs typeface="Calibri" pitchFamily="34" charset="-120"/>
+              </a:rPr>
+              <a:t>Farmbrite</a:t>
+            </a:r>
+            <a:endParaRPr lang="en-US" sz="1050" dirty="0"/>
+          </a:p>
+        </p:txBody>
+      </p:sp>
+      <p:sp>
+        <p:nvSpPr>
+          <p:cNvPr id="13" name="Shape 11"/>
+          <p:cNvSpPr/>
+          <p:nvPr/>
+        </p:nvSpPr>
+        <p:spPr>
+          <a:xfrm>
+            <a:off x="2743200" y="3044952"/>
+            <a:ext cx="1073963" cy="274320"/>
+          </a:xfrm>
+          <a:prstGeom prst="rect">
+            <a:avLst/>
+          </a:prstGeom>
+          <a:solidFill>
+            <a:srgbClr val="D8A24A"/>
+          </a:solidFill>
+          <a:ln/>
+        </p:spPr>
+      </p:sp>
+      <p:sp>
+        <p:nvSpPr>
+          <p:cNvPr id="14" name="Text 12"/>
+          <p:cNvSpPr/>
+          <p:nvPr/>
+        </p:nvSpPr>
+        <p:spPr>
+          <a:xfrm>
+            <a:off x="3890315" y="2971800"/>
+            <a:ext cx="731520" cy="402336"/>
+          </a:xfrm>
+          <a:prstGeom prst="rect">
+            <a:avLst/>
+          </a:prstGeom>
+          <a:noFill/>
+          <a:ln/>
+        </p:spPr>
+        <p:txBody>
+          <a:bodyPr wrap="square" lIns="0" tIns="0" rIns="0" bIns="0" rtlCol="0" anchor="ctr"/>
+          <a:lstStyle/>
+          <a:p>
+            <a:pPr indent="0" marL="0">
+              <a:buNone/>
+            </a:pPr>
+            <a:r>
+              <a:rPr lang="en-US" sz="1000" b="1" dirty="0">
+                <a:solidFill>
+                  <a:srgbClr val="5C6B60"/>
+                </a:solidFill>
+                <a:latin typeface="Calibri" pitchFamily="34" charset="0"/>
+                <a:ea typeface="Calibri" pitchFamily="34" charset="-122"/>
+                <a:cs typeface="Calibri" pitchFamily="34" charset="-120"/>
+              </a:rPr>
+              <a:t>$29</a:t>
+            </a:r>
+            <a:endParaRPr lang="en-US" sz="1000" dirty="0"/>
+          </a:p>
+        </p:txBody>
+      </p:sp>
+      <p:sp>
+        <p:nvSpPr>
+          <p:cNvPr id="15" name="Text 13"/>
+          <p:cNvSpPr/>
+          <p:nvPr/>
+        </p:nvSpPr>
+        <p:spPr>
+          <a:xfrm>
+            <a:off x="640080" y="3429000"/>
+            <a:ext cx="1920240" cy="402336"/>
+          </a:xfrm>
+          <a:prstGeom prst="rect">
+            <a:avLst/>
+          </a:prstGeom>
+          <a:noFill/>
+          <a:ln/>
+        </p:spPr>
+        <p:txBody>
+          <a:bodyPr wrap="square" lIns="0" tIns="0" rIns="0" bIns="0" rtlCol="0" anchor="ctr"/>
+          <a:lstStyle/>
+          <a:p>
+            <a:pPr algn="r" indent="0" marL="0">
+              <a:buNone/>
+            </a:pPr>
+            <a:r>
+              <a:rPr lang="en-US" sz="1050" dirty="0">
+                <a:solidFill>
+                  <a:srgbClr val="1A2620"/>
+                </a:solidFill>
+                <a:latin typeface="Calibri" pitchFamily="34" charset="0"/>
+                <a:ea typeface="Calibri" pitchFamily="34" charset="-122"/>
+                <a:cs typeface="Calibri" pitchFamily="34" charset="-120"/>
+              </a:rPr>
+              <a:t>Tend Pro</a:t>
+            </a:r>
+            <a:endParaRPr lang="en-US" sz="1050" dirty="0"/>
+          </a:p>
+        </p:txBody>
+      </p:sp>
+      <p:sp>
+        <p:nvSpPr>
+          <p:cNvPr id="16" name="Shape 14"/>
+          <p:cNvSpPr/>
+          <p:nvPr/>
+        </p:nvSpPr>
+        <p:spPr>
+          <a:xfrm>
+            <a:off x="2743200" y="3502152"/>
+            <a:ext cx="1110996" cy="274320"/>
+          </a:xfrm>
+          <a:prstGeom prst="rect">
+            <a:avLst/>
+          </a:prstGeom>
+          <a:solidFill>
+            <a:srgbClr val="D8A24A"/>
+          </a:solidFill>
+          <a:ln/>
+        </p:spPr>
+      </p:sp>
+      <p:sp>
+        <p:nvSpPr>
+          <p:cNvPr id="17" name="Text 15"/>
+          <p:cNvSpPr/>
+          <p:nvPr/>
+        </p:nvSpPr>
+        <p:spPr>
+          <a:xfrm>
+            <a:off x="3927348" y="3429000"/>
+            <a:ext cx="731520" cy="402336"/>
+          </a:xfrm>
+          <a:prstGeom prst="rect">
+            <a:avLst/>
+          </a:prstGeom>
+          <a:noFill/>
+          <a:ln/>
+        </p:spPr>
+        <p:txBody>
+          <a:bodyPr wrap="square" lIns="0" tIns="0" rIns="0" bIns="0" rtlCol="0" anchor="ctr"/>
+          <a:lstStyle/>
+          <a:p>
+            <a:pPr indent="0" marL="0">
+              <a:buNone/>
+            </a:pPr>
+            <a:r>
+              <a:rPr lang="en-US" sz="1000" b="1" dirty="0">
+                <a:solidFill>
+                  <a:srgbClr val="5C6B60"/>
+                </a:solidFill>
+                <a:latin typeface="Calibri" pitchFamily="34" charset="0"/>
+                <a:ea typeface="Calibri" pitchFamily="34" charset="-122"/>
+                <a:cs typeface="Calibri" pitchFamily="34" charset="-120"/>
+              </a:rPr>
+              <a:t>$30</a:t>
+            </a:r>
+            <a:endParaRPr lang="en-US" sz="1000" dirty="0"/>
+          </a:p>
+        </p:txBody>
+      </p:sp>
+      <p:sp>
+        <p:nvSpPr>
+          <p:cNvPr id="18" name="Text 16"/>
+          <p:cNvSpPr/>
+          <p:nvPr/>
+        </p:nvSpPr>
+        <p:spPr>
+          <a:xfrm>
+            <a:off x="640080" y="3886200"/>
+            <a:ext cx="1920240" cy="402336"/>
+          </a:xfrm>
+          <a:prstGeom prst="rect">
+            <a:avLst/>
+          </a:prstGeom>
+          <a:noFill/>
+          <a:ln/>
+        </p:spPr>
+        <p:txBody>
+          <a:bodyPr wrap="square" lIns="0" tIns="0" rIns="0" bIns="0" rtlCol="0" anchor="ctr"/>
+          <a:lstStyle/>
+          <a:p>
+            <a:pPr algn="r" indent="0" marL="0">
+              <a:buNone/>
+            </a:pPr>
+            <a:r>
+              <a:rPr lang="en-US" sz="1050" dirty="0">
+                <a:solidFill>
+                  <a:srgbClr val="1A2620"/>
+                </a:solidFill>
+                <a:latin typeface="Calibri" pitchFamily="34" charset="0"/>
+                <a:ea typeface="Calibri" pitchFamily="34" charset="-122"/>
+                <a:cs typeface="Calibri" pitchFamily="34" charset="-120"/>
+              </a:rPr>
+              <a:t>VeggieCropper</a:t>
+            </a:r>
+            <a:endParaRPr lang="en-US" sz="1050" dirty="0"/>
+          </a:p>
+        </p:txBody>
+      </p:sp>
+      <p:sp>
+        <p:nvSpPr>
+          <p:cNvPr id="19" name="Shape 17"/>
+          <p:cNvSpPr/>
+          <p:nvPr/>
+        </p:nvSpPr>
+        <p:spPr>
+          <a:xfrm>
+            <a:off x="2743200" y="3959352"/>
+            <a:ext cx="1370228" cy="274320"/>
+          </a:xfrm>
+          <a:prstGeom prst="rect">
+            <a:avLst/>
+          </a:prstGeom>
+          <a:solidFill>
+            <a:srgbClr val="D8A24A"/>
+          </a:solidFill>
+          <a:ln/>
+        </p:spPr>
+      </p:sp>
+      <p:sp>
+        <p:nvSpPr>
+          <p:cNvPr id="20" name="Text 18"/>
+          <p:cNvSpPr/>
+          <p:nvPr/>
+        </p:nvSpPr>
+        <p:spPr>
+          <a:xfrm>
+            <a:off x="4186580" y="3886200"/>
+            <a:ext cx="731520" cy="402336"/>
+          </a:xfrm>
+          <a:prstGeom prst="rect">
+            <a:avLst/>
+          </a:prstGeom>
+          <a:noFill/>
+          <a:ln/>
+        </p:spPr>
+        <p:txBody>
+          <a:bodyPr wrap="square" lIns="0" tIns="0" rIns="0" bIns="0" rtlCol="0" anchor="ctr"/>
+          <a:lstStyle/>
+          <a:p>
+            <a:pPr indent="0" marL="0">
+              <a:buNone/>
+            </a:pPr>
+            <a:r>
+              <a:rPr lang="en-US" sz="1000" b="1" dirty="0">
+                <a:solidFill>
+                  <a:srgbClr val="5C6B60"/>
+                </a:solidFill>
+                <a:latin typeface="Calibri" pitchFamily="34" charset="0"/>
+                <a:ea typeface="Calibri" pitchFamily="34" charset="-122"/>
+                <a:cs typeface="Calibri" pitchFamily="34" charset="-120"/>
+              </a:rPr>
+              <a:t>$37</a:t>
+            </a:r>
+            <a:endParaRPr lang="en-US" sz="1000" dirty="0"/>
+          </a:p>
+        </p:txBody>
+      </p:sp>
+      <p:sp>
+        <p:nvSpPr>
+          <p:cNvPr id="21" name="Text 19"/>
+          <p:cNvSpPr/>
+          <p:nvPr/>
+        </p:nvSpPr>
+        <p:spPr>
+          <a:xfrm>
+            <a:off x="640080" y="4343400"/>
+            <a:ext cx="1920240" cy="402336"/>
+          </a:xfrm>
+          <a:prstGeom prst="rect">
+            <a:avLst/>
+          </a:prstGeom>
+          <a:noFill/>
+          <a:ln/>
+        </p:spPr>
+        <p:txBody>
+          <a:bodyPr wrap="square" lIns="0" tIns="0" rIns="0" bIns="0" rtlCol="0" anchor="ctr"/>
+          <a:lstStyle/>
+          <a:p>
+            <a:pPr algn="r" indent="0" marL="0">
+              <a:buNone/>
+            </a:pPr>
+            <a:r>
+              <a:rPr lang="en-US" sz="1050" dirty="0">
+                <a:solidFill>
+                  <a:srgbClr val="1A2620"/>
+                </a:solidFill>
+                <a:latin typeface="Calibri" pitchFamily="34" charset="0"/>
+                <a:ea typeface="Calibri" pitchFamily="34" charset="-122"/>
+                <a:cs typeface="Calibri" pitchFamily="34" charset="-120"/>
+              </a:rPr>
+              <a:t>AgriWebb</a:t>
+            </a:r>
+            <a:endParaRPr lang="en-US" sz="1050" dirty="0"/>
+          </a:p>
+        </p:txBody>
+      </p:sp>
+      <p:sp>
+        <p:nvSpPr>
+          <p:cNvPr id="22" name="Shape 20"/>
+          <p:cNvSpPr/>
+          <p:nvPr/>
+        </p:nvSpPr>
+        <p:spPr>
+          <a:xfrm>
+            <a:off x="2743200" y="4416552"/>
+            <a:ext cx="2036826" cy="274320"/>
+          </a:xfrm>
+          <a:prstGeom prst="rect">
+            <a:avLst/>
+          </a:prstGeom>
+          <a:solidFill>
+            <a:srgbClr val="2E7D4F"/>
+          </a:solidFill>
+          <a:ln/>
+        </p:spPr>
+      </p:sp>
+      <p:sp>
+        <p:nvSpPr>
+          <p:cNvPr id="23" name="Text 21"/>
+          <p:cNvSpPr/>
+          <p:nvPr/>
+        </p:nvSpPr>
+        <p:spPr>
+          <a:xfrm>
+            <a:off x="4853178" y="4343400"/>
+            <a:ext cx="731520" cy="402336"/>
+          </a:xfrm>
+          <a:prstGeom prst="rect">
+            <a:avLst/>
+          </a:prstGeom>
+          <a:noFill/>
+          <a:ln/>
+        </p:spPr>
+        <p:txBody>
+          <a:bodyPr wrap="square" lIns="0" tIns="0" rIns="0" bIns="0" rtlCol="0" anchor="ctr"/>
+          <a:lstStyle/>
+          <a:p>
+            <a:pPr indent="0" marL="0">
+              <a:buNone/>
+            </a:pPr>
+            <a:r>
+              <a:rPr lang="en-US" sz="1000" b="1" dirty="0">
+                <a:solidFill>
+                  <a:srgbClr val="5C6B60"/>
+                </a:solidFill>
+                <a:latin typeface="Calibri" pitchFamily="34" charset="0"/>
+                <a:ea typeface="Calibri" pitchFamily="34" charset="-122"/>
+                <a:cs typeface="Calibri" pitchFamily="34" charset="-120"/>
+              </a:rPr>
+              <a:t>$55</a:t>
+            </a:r>
+            <a:endParaRPr lang="en-US" sz="1000" dirty="0"/>
+          </a:p>
+        </p:txBody>
+      </p:sp>
+      <p:sp>
+        <p:nvSpPr>
+          <p:cNvPr id="24" name="Text 22"/>
+          <p:cNvSpPr/>
+          <p:nvPr/>
+        </p:nvSpPr>
+        <p:spPr>
+          <a:xfrm>
+            <a:off x="640080" y="4800600"/>
+            <a:ext cx="1920240" cy="402336"/>
+          </a:xfrm>
+          <a:prstGeom prst="rect">
+            <a:avLst/>
+          </a:prstGeom>
+          <a:noFill/>
+          <a:ln/>
+        </p:spPr>
+        <p:txBody>
+          <a:bodyPr wrap="square" lIns="0" tIns="0" rIns="0" bIns="0" rtlCol="0" anchor="ctr"/>
+          <a:lstStyle/>
+          <a:p>
+            <a:pPr algn="r" indent="0" marL="0">
+              <a:buNone/>
+            </a:pPr>
+            <a:r>
+              <a:rPr lang="en-US" sz="1050" dirty="0">
+                <a:solidFill>
+                  <a:srgbClr val="1A2620"/>
+                </a:solidFill>
+                <a:latin typeface="Calibri" pitchFamily="34" charset="0"/>
+                <a:ea typeface="Calibri" pitchFamily="34" charset="-122"/>
+                <a:cs typeface="Calibri" pitchFamily="34" charset="-120"/>
+              </a:rPr>
+              <a:t>Local Line</a:t>
+            </a:r>
+            <a:endParaRPr lang="en-US" sz="1050" dirty="0"/>
+          </a:p>
+        </p:txBody>
+      </p:sp>
+      <p:sp>
+        <p:nvSpPr>
+          <p:cNvPr id="25" name="Shape 23"/>
+          <p:cNvSpPr/>
+          <p:nvPr/>
+        </p:nvSpPr>
+        <p:spPr>
+          <a:xfrm>
+            <a:off x="2743200" y="4873752"/>
+            <a:ext cx="3666287" cy="274320"/>
+          </a:xfrm>
+          <a:prstGeom prst="rect">
+            <a:avLst/>
+          </a:prstGeom>
+          <a:solidFill>
+            <a:srgbClr val="2E7D4F"/>
+          </a:solidFill>
+          <a:ln/>
+        </p:spPr>
+      </p:sp>
+      <p:sp>
+        <p:nvSpPr>
+          <p:cNvPr id="26" name="Text 24"/>
+          <p:cNvSpPr/>
+          <p:nvPr/>
+        </p:nvSpPr>
+        <p:spPr>
+          <a:xfrm>
+            <a:off x="6482639" y="4800600"/>
+            <a:ext cx="731520" cy="402336"/>
+          </a:xfrm>
+          <a:prstGeom prst="rect">
+            <a:avLst/>
+          </a:prstGeom>
+          <a:noFill/>
+          <a:ln/>
+        </p:spPr>
+        <p:txBody>
+          <a:bodyPr wrap="square" lIns="0" tIns="0" rIns="0" bIns="0" rtlCol="0" anchor="ctr"/>
+          <a:lstStyle/>
+          <a:p>
+            <a:pPr indent="0" marL="0">
+              <a:buNone/>
+            </a:pPr>
+            <a:r>
+              <a:rPr lang="en-US" sz="1000" b="1" dirty="0">
+                <a:solidFill>
+                  <a:srgbClr val="5C6B60"/>
+                </a:solidFill>
+                <a:latin typeface="Calibri" pitchFamily="34" charset="0"/>
+                <a:ea typeface="Calibri" pitchFamily="34" charset="-122"/>
+                <a:cs typeface="Calibri" pitchFamily="34" charset="-120"/>
+              </a:rPr>
+              <a:t>$99</a:t>
+            </a:r>
+            <a:endParaRPr lang="en-US" sz="1000" dirty="0"/>
+          </a:p>
+        </p:txBody>
+      </p:sp>
+      <p:sp>
+        <p:nvSpPr>
+          <p:cNvPr id="27" name="Text 25"/>
+          <p:cNvSpPr/>
+          <p:nvPr/>
+        </p:nvSpPr>
+        <p:spPr>
+          <a:xfrm>
+            <a:off x="640080" y="5257800"/>
+            <a:ext cx="1920240" cy="402336"/>
+          </a:xfrm>
+          <a:prstGeom prst="rect">
+            <a:avLst/>
+          </a:prstGeom>
+          <a:noFill/>
+          <a:ln/>
+        </p:spPr>
+        <p:txBody>
+          <a:bodyPr wrap="square" lIns="0" tIns="0" rIns="0" bIns="0" rtlCol="0" anchor="ctr"/>
+          <a:lstStyle/>
+          <a:p>
+            <a:pPr algn="r" indent="0" marL="0">
+              <a:buNone/>
+            </a:pPr>
+            <a:r>
+              <a:rPr lang="en-US" sz="1050" dirty="0">
+                <a:solidFill>
+                  <a:srgbClr val="1A2620"/>
+                </a:solidFill>
+                <a:latin typeface="Calibri" pitchFamily="34" charset="0"/>
+                <a:ea typeface="Calibri" pitchFamily="34" charset="-122"/>
+                <a:cs typeface="Calibri" pitchFamily="34" charset="-120"/>
+              </a:rPr>
+              <a:t>Solara</a:t>
+            </a:r>
+            <a:endParaRPr lang="en-US" sz="1050" dirty="0"/>
+          </a:p>
+        </p:txBody>
+      </p:sp>
+      <p:sp>
+        <p:nvSpPr>
+          <p:cNvPr id="28" name="Shape 26"/>
+          <p:cNvSpPr/>
+          <p:nvPr/>
+        </p:nvSpPr>
+        <p:spPr>
+          <a:xfrm>
+            <a:off x="2743200" y="5330952"/>
+            <a:ext cx="3666287" cy="274320"/>
+          </a:xfrm>
+          <a:prstGeom prst="rect">
+            <a:avLst/>
+          </a:prstGeom>
+          <a:solidFill>
+            <a:srgbClr val="2E7D4F"/>
+          </a:solidFill>
+          <a:ln/>
+        </p:spPr>
+      </p:sp>
+      <p:sp>
+        <p:nvSpPr>
+          <p:cNvPr id="29" name="Text 27"/>
+          <p:cNvSpPr/>
+          <p:nvPr/>
+        </p:nvSpPr>
+        <p:spPr>
+          <a:xfrm>
+            <a:off x="6482639" y="5257800"/>
+            <a:ext cx="731520" cy="402336"/>
+          </a:xfrm>
+          <a:prstGeom prst="rect">
+            <a:avLst/>
+          </a:prstGeom>
+          <a:noFill/>
+          <a:ln/>
+        </p:spPr>
+        <p:txBody>
+          <a:bodyPr wrap="square" lIns="0" tIns="0" rIns="0" bIns="0" rtlCol="0" anchor="ctr"/>
+          <a:lstStyle/>
+          <a:p>
+            <a:pPr indent="0" marL="0">
+              <a:buNone/>
+            </a:pPr>
+            <a:r>
+              <a:rPr lang="en-US" sz="1000" b="1" dirty="0">
+                <a:solidFill>
+                  <a:srgbClr val="5C6B60"/>
+                </a:solidFill>
+                <a:latin typeface="Calibri" pitchFamily="34" charset="0"/>
+                <a:ea typeface="Calibri" pitchFamily="34" charset="-122"/>
+                <a:cs typeface="Calibri" pitchFamily="34" charset="-120"/>
+              </a:rPr>
+              <a:t>$99</a:t>
+            </a:r>
+            <a:endParaRPr lang="en-US" sz="1000" dirty="0"/>
+          </a:p>
+        </p:txBody>
+      </p:sp>
+      <p:sp>
+        <p:nvSpPr>
+          <p:cNvPr id="30" name="Text 28"/>
+          <p:cNvSpPr/>
+          <p:nvPr/>
+        </p:nvSpPr>
+        <p:spPr>
+          <a:xfrm>
+            <a:off x="640080" y="5788152"/>
+            <a:ext cx="6583680" cy="274320"/>
+          </a:xfrm>
+          <a:prstGeom prst="rect">
+            <a:avLst/>
+          </a:prstGeom>
+          <a:noFill/>
+          <a:ln/>
+        </p:spPr>
+        <p:txBody>
+          <a:bodyPr wrap="square" lIns="0" tIns="0" rIns="0" bIns="0" rtlCol="0" anchor="ctr"/>
+          <a:lstStyle/>
+          <a:p>
+            <a:pPr indent="0" marL="0">
+              <a:buNone/>
+            </a:pPr>
+            <a:r>
+              <a:rPr lang="en-US" sz="950" i="1" dirty="0">
+                <a:solidFill>
+                  <a:srgbClr val="5C6B60"/>
+                </a:solidFill>
+                <a:latin typeface="Calibri" pitchFamily="34" charset="0"/>
+                <a:ea typeface="Calibri" pitchFamily="34" charset="-122"/>
+                <a:cs typeface="Calibri" pitchFamily="34" charset="-120"/>
+              </a:rPr>
+              <a:t>Monthly $ equivalent  ·  Croptracker ~$275 (enterprise, off-scale)</a:t>
+            </a:r>
+            <a:endParaRPr lang="en-US" sz="950" dirty="0"/>
+          </a:p>
+        </p:txBody>
+      </p:sp>
+      <p:sp>
+        <p:nvSpPr>
+          <p:cNvPr id="31" name="Shape 29"/>
           <p:cNvSpPr/>
           <p:nvPr/>
         </p:nvSpPr>
@@ -5837,7 +6433,7 @@
       </p:sp>
       <p:sp>
         <p:nvSpPr>
-          <p:cNvPr id="6" name="Text 3"/>
+          <p:cNvPr id="32" name="Text 30"/>
           <p:cNvSpPr/>
           <p:nvPr/>
         </p:nvSpPr>
@@ -5876,7 +6472,7 @@
       </p:sp>
       <p:sp>
         <p:nvSpPr>
-          <p:cNvPr id="7" name="Text 4"/>
+          <p:cNvPr id="33" name="Text 31"/>
           <p:cNvSpPr/>
           <p:nvPr/>
         </p:nvSpPr>
@@ -5915,7 +6511,7 @@
       </p:sp>
       <p:sp>
         <p:nvSpPr>
-          <p:cNvPr id="8" name="Text 5"/>
+          <p:cNvPr id="34" name="Text 32"/>
           <p:cNvSpPr/>
           <p:nvPr/>
         </p:nvSpPr>
@@ -5954,7 +6550,7 @@
       </p:sp>
       <p:sp>
         <p:nvSpPr>
-          <p:cNvPr id="9" name="Text 6"/>
+          <p:cNvPr id="35" name="Text 33"/>
           <p:cNvSpPr/>
           <p:nvPr/>
         </p:nvSpPr>
@@ -6039,7 +6635,7 @@
       </p:sp>
       <p:sp>
         <p:nvSpPr>
-          <p:cNvPr id="10" name="Text 7"/>
+          <p:cNvPr id="36" name="Text 34"/>
           <p:cNvSpPr/>
           <p:nvPr/>
         </p:nvSpPr>
@@ -6078,7 +6674,7 @@
       </p:sp>
       <p:sp>
         <p:nvSpPr>
-          <p:cNvPr id="11" name="Text 8"/>
+          <p:cNvPr id="37" name="Text 35"/>
           <p:cNvSpPr/>
           <p:nvPr/>
         </p:nvSpPr>

</xml_diff>